<commit_message>
Replace native charts on slides 9 and 11 with labelled images
Native pptxgenjs charts lost their category labels in some viewers.
build/slide_figs.py renders both as PNG: slide 9 names each phase,
groups destroy vs create, and shows the run range; a 'How to read it'
box explains the chart.

Co-Authored-By: Claude Opus 5.5 <noreply@anthropic.com>
</commit_message>
<xml_diff>
--- a/assessment2/KAO_Leangseng_ITRM_Assessment2_Presentation.pptx
+++ b/assessment2/KAO_Leangseng_ITRM_Assessment2_Presentation.pptx
@@ -119,584 +119,6 @@
     </a:lvl9pPr>
   </p:defaultTextStyle>
 </p:presentation>
-</file>
-
-<file path=ppt/charts/chart1.xml><?xml version="1.0" encoding="utf-8"?>
-<c:chartSpace xmlns:c="http://schemas.openxmlformats.org/drawingml/2006/chart" xmlns:a="http://schemas.openxmlformats.org/drawingml/2006/main" xmlns:r="http://schemas.openxmlformats.org/officeDocument/2006/relationships">
-  <c:date1904 val="0"/>
-  <c:roundedCorners val="1"/>
-  <c:chart>
-    <c:title>
-      <c:tx>
-        <c:rich>
-          <a:bodyPr/>
-          <a:lstStyle/>
-          <a:p>
-            <a:pPr>
-              <a:defRPr sz="1200" b="0" i="0" u="none" strike="noStrike">
-                <a:solidFill>
-                  <a:srgbClr val="1E1A2B"/>
-                </a:solidFill>
-                <a:latin typeface="+mn-lt"/>
-              </a:defRPr>
-            </a:pPr>
-            <a:r>
-              <a:rPr sz="1200" b="0" i="0" u="none" strike="noStrike">
-                <a:solidFill>
-                  <a:srgbClr val="1E1A2B"/>
-                </a:solidFill>
-                <a:latin typeface="+mn-lt"/>
-              </a:rPr>
-              <a:t>Mean minutes per phase (30 measured rebuilds)</a:t>
-            </a:r>
-          </a:p>
-        </c:rich>
-      </c:tx>
-      <c:layout/>
-      <c:overlay val="0"/>
-    </c:title>
-    <c:autoTitleDeleted val="0"/>
-    <c:plotArea>
-      <c:layout/>
-      <c:barChart>
-        <c:barDir val="bar"/>
-        <c:grouping val="clustered"/>
-        <c:varyColors val="0"/>
-        <c:ser>
-          <c:idx val="0"/>
-          <c:order val="0"/>
-          <c:tx>
-            <c:strRef>
-              <c:f>Sheet1!$B$1</c:f>
-              <c:strCache>
-                <c:ptCount val="1"/>
-                <c:pt idx="0">
-                  <c:v>GitHub Actions (n = 30)</c:v>
-                </c:pt>
-              </c:strCache>
-            </c:strRef>
-          </c:tx>
-          <c:spPr>
-            <a:solidFill>
-              <a:srgbClr val="2A78D6"/>
-            </a:solidFill>
-            <a:effectLst/>
-          </c:spPr>
-          <c:invertIfNegative val="0"/>
-          <c:dLbls>
-            <c:numFmt formatCode="0.0" sourceLinked="0"/>
-            <c:txPr>
-              <a:bodyPr/>
-              <a:lstStyle/>
-              <a:p>
-                <a:pPr>
-                  <a:defRPr b="0" i="0" strike="noStrike" sz="800" u="none">
-                    <a:solidFill>
-                      <a:srgbClr val="6B6680"/>
-                    </a:solidFill>
-                    <a:latin typeface="+mn-lt"/>
-                  </a:defRPr>
-                </a:pPr>
-              </a:p>
-            </c:txPr>
-            <c:showLegendKey val="0"/>
-            <c:showVal val="1"/>
-            <c:showCatName val="0"/>
-            <c:showSerName val="0"/>
-            <c:showPercent val="0"/>
-            <c:showBubbleSize val="0"/>
-            <c:showLeaderLines val="0"/>
-          </c:dLbls>
-          <c:cat>
-            <c:multiLvlStrRef>
-              <c:f>Sheet1!$A$2:$A$8</c:f>
-              <c:multiLvlStrCache>
-                <c:ptCount val="7"/>
-                <c:lvl>
-                  <c:pt idx="0">
-                    <c:v>Destroy deployments</c:v>
-                  </c:pt>
-                  <c:pt idx="1">
-                    <c:v>Destroy infrastructures</c:v>
-                  </c:pt>
-                  <c:pt idx="2">
-                    <c:v>Destroy remote-state</c:v>
-                  </c:pt>
-                  <c:pt idx="3">
-                    <c:v>Create remote-state</c:v>
-                  </c:pt>
-                  <c:pt idx="4">
-                    <c:v>Create infrastructures</c:v>
-                  </c:pt>
-                  <c:pt idx="5">
-                    <c:v>Create deployments</c:v>
-                  </c:pt>
-                  <c:pt idx="6">
-                    <c:v>Wait until healthy</c:v>
-                  </c:pt>
-                </c:lvl>
-              </c:multiLvlStrCache>
-            </c:multiLvlStrRef>
-          </c:cat>
-          <c:val>
-            <c:numRef>
-              <c:f>Sheet1!$B$2:$B$8</c:f>
-              <c:numCache>
-                <c:formatCode>General</c:formatCode>
-                <c:ptCount val="7"/>
-                <c:pt idx="0">
-                  <c:v>18.2</c:v>
-                </c:pt>
-                <c:pt idx="1">
-                  <c:v>1.5</c:v>
-                </c:pt>
-                <c:pt idx="2">
-                  <c:v>0.4</c:v>
-                </c:pt>
-                <c:pt idx="3">
-                  <c:v>1.2</c:v>
-                </c:pt>
-                <c:pt idx="4">
-                  <c:v>3.1</c:v>
-                </c:pt>
-                <c:pt idx="5">
-                  <c:v>2.7</c:v>
-                </c:pt>
-                <c:pt idx="6">
-                  <c:v>1.3</c:v>
-                </c:pt>
-              </c:numCache>
-            </c:numRef>
-          </c:val>
-        </c:ser>
-        <c:dLbls>
-          <c:numFmt formatCode="0.0" sourceLinked="0"/>
-          <c:txPr>
-            <a:bodyPr/>
-            <a:lstStyle/>
-            <a:p>
-              <a:pPr>
-                <a:defRPr b="0" i="0" strike="noStrike" sz="800" u="none">
-                  <a:solidFill>
-                    <a:srgbClr val="6B6680"/>
-                  </a:solidFill>
-                  <a:latin typeface="+mn-lt"/>
-                </a:defRPr>
-              </a:pPr>
-            </a:p>
-          </c:txPr>
-          <c:showLegendKey val="0"/>
-          <c:showVal val="1"/>
-          <c:showCatName val="0"/>
-          <c:showSerName val="0"/>
-          <c:showPercent val="0"/>
-          <c:showBubbleSize val="0"/>
-          <c:showLeaderLines val="0"/>
-        </c:dLbls>
-        <c:gapWidth val="40"/>
-        <c:overlap val="0"/>
-        <c:axId val="2094734554"/>
-        <c:axId val="2094734552"/>
-        <c:axId val="2094734556"/>
-      </c:barChart>
-      <c:catAx>
-        <c:axId val="2094734554"/>
-        <c:scaling>
-          <c:orientation val="maxMin"/>
-        </c:scaling>
-        <c:delete val="0"/>
-        <c:axPos val="l"/>
-        <c:numFmt formatCode="General" sourceLinked="1"/>
-        <c:majorTickMark val="out"/>
-        <c:minorTickMark val="none"/>
-        <c:tickLblPos val="nextTo"/>
-        <c:spPr>
-          <a:ln w="12700" cap="flat">
-            <a:solidFill>
-              <a:srgbClr val="888888"/>
-            </a:solidFill>
-            <a:prstDash val="solid"/>
-            <a:round/>
-          </a:ln>
-        </c:spPr>
-        <c:txPr>
-          <a:bodyPr/>
-          <a:lstStyle/>
-          <a:p>
-            <a:pPr>
-              <a:defRPr sz="900" b="0" i="0" u="none" strike="noStrike">
-                <a:solidFill>
-                  <a:srgbClr val="6B6680"/>
-                </a:solidFill>
-                <a:latin typeface="+mn-lt"/>
-              </a:defRPr>
-            </a:pPr>
-            <a:endParaRPr lang="en-US"/>
-          </a:p>
-        </c:txPr>
-        <c:crossAx val="2094734552"/>
-        <c:crosses val="autoZero"/>
-        <c:auto val="1"/>
-        <c:lblAlgn val="ctr"/>
-        <c:noMultiLvlLbl val="1"/>
-      </c:catAx>
-      <c:valAx>
-        <c:axId val="2094734552"/>
-        <c:scaling>
-          <c:orientation val="minMax"/>
-        </c:scaling>
-        <c:delete val="0"/>
-        <c:axPos val="b"/>
-        <c:majorGridlines>
-          <c:spPr>
-            <a:ln w="6350" cap="flat">
-              <a:solidFill>
-                <a:srgbClr val="E4E3DF"/>
-              </a:solidFill>
-              <a:prstDash val="solid"/>
-              <a:round/>
-            </a:ln>
-          </c:spPr>
-        </c:majorGridlines>
-        <c:numFmt formatCode="General" sourceLinked="0"/>
-        <c:majorTickMark val="out"/>
-        <c:minorTickMark val="none"/>
-        <c:tickLblPos val="low"/>
-        <c:spPr>
-          <a:ln w="12700" cap="flat">
-            <a:solidFill>
-              <a:srgbClr val="888888"/>
-            </a:solidFill>
-            <a:prstDash val="solid"/>
-            <a:round/>
-          </a:ln>
-        </c:spPr>
-        <c:txPr>
-          <a:bodyPr/>
-          <a:lstStyle/>
-          <a:p>
-            <a:pPr>
-              <a:defRPr sz="800" b="0" i="0" u="none" strike="noStrike">
-                <a:solidFill>
-                  <a:srgbClr val="6B6680"/>
-                </a:solidFill>
-                <a:latin typeface="+mn-lt"/>
-              </a:defRPr>
-            </a:pPr>
-            <a:endParaRPr lang="en-US"/>
-          </a:p>
-        </c:txPr>
-        <c:crossAx val="2094734554"/>
-        <c:crosses val="autoZero"/>
-        <c:crossBetween val="between"/>
-      </c:valAx>
-      <c:spPr>
-        <a:noFill/>
-        <a:ln>
-          <a:noFill/>
-        </a:ln>
-        <a:effectLst/>
-      </c:spPr>
-    </c:plotArea>
-    <c:plotVisOnly val="1"/>
-    <c:dispBlanksAs val="span"/>
-  </c:chart>
-  <c:spPr>
-    <a:noFill/>
-    <a:ln>
-      <a:noFill/>
-    </a:ln>
-    <a:effectLst/>
-  </c:spPr>
-  <c:externalData r:id="rId1">
-    <c:autoUpdate val="0"/>
-  </c:externalData>
-</c:chartSpace>
-</file>
-
-<file path=ppt/charts/chart2.xml><?xml version="1.0" encoding="utf-8"?>
-<c:chartSpace xmlns:c="http://schemas.openxmlformats.org/drawingml/2006/chart" xmlns:a="http://schemas.openxmlformats.org/drawingml/2006/main" xmlns:r="http://schemas.openxmlformats.org/officeDocument/2006/relationships">
-  <c:date1904 val="0"/>
-  <c:roundedCorners val="1"/>
-  <c:chart>
-    <c:title>
-      <c:tx>
-        <c:rich>
-          <a:bodyPr/>
-          <a:lstStyle/>
-          <a:p>
-            <a:pPr>
-              <a:defRPr sz="1200" b="0" i="0" u="none" strike="noStrike">
-                <a:solidFill>
-                  <a:srgbClr val="1E1A2B"/>
-                </a:solidFill>
-                <a:latin typeface="+mn-lt"/>
-              </a:defRPr>
-            </a:pPr>
-            <a:r>
-              <a:rPr sz="1200" b="0" i="0" u="none" strike="noStrike">
-                <a:solidFill>
-                  <a:srgbClr val="1E1A2B"/>
-                </a:solidFill>
-                <a:latin typeface="+mn-lt"/>
-              </a:rPr>
-              <a:t>Minutes to build from empty</a:t>
-            </a:r>
-          </a:p>
-        </c:rich>
-      </c:tx>
-      <c:layout/>
-      <c:overlay val="0"/>
-    </c:title>
-    <c:autoTitleDeleted val="0"/>
-    <c:plotArea>
-      <c:layout/>
-      <c:barChart>
-        <c:barDir val="col"/>
-        <c:grouping val="clustered"/>
-        <c:varyColors val="0"/>
-        <c:ser>
-          <c:idx val="0"/>
-          <c:order val="0"/>
-          <c:tx>
-            <c:strRef>
-              <c:f>Sheet1!$B$1</c:f>
-              <c:strCache>
-                <c:ptCount val="1"/>
-                <c:pt idx="0">
-                  <c:v>Minutes to build from empty</c:v>
-                </c:pt>
-              </c:strCache>
-            </c:strRef>
-          </c:tx>
-          <c:spPr>
-            <a:solidFill>
-              <a:srgbClr val="2A78D6"/>
-            </a:solidFill>
-            <a:effectLst/>
-          </c:spPr>
-          <c:invertIfNegative val="0"/>
-          <c:dLbls>
-            <c:numFmt formatCode="0.0" sourceLinked="0"/>
-            <c:txPr>
-              <a:bodyPr/>
-              <a:lstStyle/>
-              <a:p>
-                <a:pPr>
-                  <a:defRPr b="0" i="0" strike="noStrike" sz="1100" u="none">
-                    <a:solidFill>
-                      <a:srgbClr val="1E1A2B"/>
-                    </a:solidFill>
-                    <a:latin typeface="+mn-lt"/>
-                  </a:defRPr>
-                </a:pPr>
-              </a:p>
-            </c:txPr>
-            <c:showLegendKey val="0"/>
-            <c:showVal val="1"/>
-            <c:showCatName val="0"/>
-            <c:showSerName val="0"/>
-            <c:showPercent val="0"/>
-            <c:showBubbleSize val="0"/>
-            <c:showLeaderLines val="0"/>
-          </c:dLbls>
-          <c:dPt>
-            <c:idx val="0"/>
-            <c:invertIfNegative val="0"/>
-            <c:bubble3D val="0"/>
-            <c:spPr>
-              <a:solidFill>
-                <a:srgbClr val="2A78D6"/>
-              </a:solidFill>
-              <a:effectLst/>
-            </c:spPr>
-          </c:dPt>
-          <c:dPt>
-            <c:idx val="1"/>
-            <c:invertIfNegative val="0"/>
-            <c:bubble3D val="0"/>
-            <c:spPr>
-              <a:solidFill>
-                <a:srgbClr val="EB6834"/>
-              </a:solidFill>
-              <a:effectLst/>
-            </c:spPr>
-          </c:dPt>
-          <c:cat>
-            <c:multiLvlStrRef>
-              <c:f>Sheet1!$A$2:$A$3</c:f>
-              <c:multiLvlStrCache>
-                <c:ptCount val="2"/>
-                <c:lvl>
-                  <c:pt idx="0">
-                    <c:v>Terraform via GitHub Actions (measured)</c:v>
-                  </c:pt>
-                  <c:pt idx="1">
-                    <c:v>Manual AWS console (SIMULATED)</c:v>
-                  </c:pt>
-                </c:lvl>
-              </c:multiLvlStrCache>
-            </c:multiLvlStrRef>
-          </c:cat>
-          <c:val>
-            <c:numRef>
-              <c:f>Sheet1!$B$2:$B$3</c:f>
-              <c:numCache>
-                <c:formatCode>General</c:formatCode>
-                <c:ptCount val="2"/>
-                <c:pt idx="0">
-                  <c:v>8.3</c:v>
-                </c:pt>
-                <c:pt idx="1">
-                  <c:v>105.3</c:v>
-                </c:pt>
-              </c:numCache>
-            </c:numRef>
-          </c:val>
-        </c:ser>
-        <c:dLbls>
-          <c:numFmt formatCode="0.0" sourceLinked="0"/>
-          <c:txPr>
-            <a:bodyPr/>
-            <a:lstStyle/>
-            <a:p>
-              <a:pPr>
-                <a:defRPr b="0" i="0" strike="noStrike" sz="1100" u="none">
-                  <a:solidFill>
-                    <a:srgbClr val="1E1A2B"/>
-                  </a:solidFill>
-                  <a:latin typeface="+mn-lt"/>
-                </a:defRPr>
-              </a:pPr>
-            </a:p>
-          </c:txPr>
-          <c:showLegendKey val="0"/>
-          <c:showVal val="1"/>
-          <c:showCatName val="0"/>
-          <c:showSerName val="0"/>
-          <c:showPercent val="0"/>
-          <c:showBubbleSize val="0"/>
-          <c:showLeaderLines val="0"/>
-        </c:dLbls>
-        <c:gapWidth val="60"/>
-        <c:overlap val="0"/>
-        <c:axId val="2094734554"/>
-        <c:axId val="2094734552"/>
-        <c:axId val="2094734556"/>
-      </c:barChart>
-      <c:catAx>
-        <c:axId val="2094734554"/>
-        <c:scaling>
-          <c:orientation val="minMax"/>
-        </c:scaling>
-        <c:delete val="0"/>
-        <c:axPos val="b"/>
-        <c:numFmt formatCode="General" sourceLinked="1"/>
-        <c:majorTickMark val="out"/>
-        <c:minorTickMark val="none"/>
-        <c:tickLblPos val="low"/>
-        <c:spPr>
-          <a:ln w="12700" cap="flat">
-            <a:solidFill>
-              <a:srgbClr val="888888"/>
-            </a:solidFill>
-            <a:prstDash val="solid"/>
-            <a:round/>
-          </a:ln>
-        </c:spPr>
-        <c:txPr>
-          <a:bodyPr/>
-          <a:lstStyle/>
-          <a:p>
-            <a:pPr>
-              <a:defRPr sz="900" b="0" i="0" u="none" strike="noStrike">
-                <a:solidFill>
-                  <a:srgbClr val="6B6680"/>
-                </a:solidFill>
-                <a:latin typeface="+mn-lt"/>
-              </a:defRPr>
-            </a:pPr>
-            <a:endParaRPr lang="en-US"/>
-          </a:p>
-        </c:txPr>
-        <c:crossAx val="2094734552"/>
-        <c:crosses val="autoZero"/>
-        <c:auto val="1"/>
-        <c:lblAlgn val="ctr"/>
-        <c:noMultiLvlLbl val="1"/>
-      </c:catAx>
-      <c:valAx>
-        <c:axId val="2094734552"/>
-        <c:scaling>
-          <c:orientation val="minMax"/>
-        </c:scaling>
-        <c:delete val="0"/>
-        <c:axPos val="l"/>
-        <c:majorGridlines>
-          <c:spPr>
-            <a:ln w="6350" cap="flat">
-              <a:solidFill>
-                <a:srgbClr val="E4E3DF"/>
-              </a:solidFill>
-              <a:prstDash val="solid"/>
-              <a:round/>
-            </a:ln>
-          </c:spPr>
-        </c:majorGridlines>
-        <c:numFmt formatCode="General" sourceLinked="0"/>
-        <c:majorTickMark val="out"/>
-        <c:minorTickMark val="none"/>
-        <c:tickLblPos val="nextTo"/>
-        <c:spPr>
-          <a:ln w="12700" cap="flat">
-            <a:solidFill>
-              <a:srgbClr val="888888"/>
-            </a:solidFill>
-            <a:prstDash val="solid"/>
-            <a:round/>
-          </a:ln>
-        </c:spPr>
-        <c:txPr>
-          <a:bodyPr/>
-          <a:lstStyle/>
-          <a:p>
-            <a:pPr>
-              <a:defRPr sz="800" b="0" i="0" u="none" strike="noStrike">
-                <a:solidFill>
-                  <a:srgbClr val="6B6680"/>
-                </a:solidFill>
-                <a:latin typeface="+mn-lt"/>
-              </a:defRPr>
-            </a:pPr>
-            <a:endParaRPr lang="en-US"/>
-          </a:p>
-        </c:txPr>
-        <c:crossAx val="2094734554"/>
-        <c:crosses val="autoZero"/>
-        <c:crossBetween val="between"/>
-      </c:valAx>
-      <c:spPr>
-        <a:noFill/>
-        <a:ln>
-          <a:noFill/>
-        </a:ln>
-        <a:effectLst/>
-      </c:spPr>
-    </c:plotArea>
-    <c:plotVisOnly val="1"/>
-    <c:dispBlanksAs val="span"/>
-  </c:chart>
-  <c:spPr>
-    <a:noFill/>
-    <a:ln>
-      <a:noFill/>
-    </a:ln>
-    <a:effectLst/>
-  </c:spPr>
-  <c:externalData r:id="rId1">
-    <c:autoUpdate val="0"/>
-  </c:externalData>
-</c:chartSpace>
 </file>
 
 <file path=ppt/notesMasters/notesMaster1.xml><?xml version="1.0" encoding="utf-8"?>
@@ -4804,22 +4226,30 @@
           </a:p>
         </p:txBody>
       </p:sp>
-      <p:graphicFrame>
-        <p:nvGraphicFramePr>
-          <p:cNvPr id="4" name="h1-chart" descr=""/>
-          <p:cNvGraphicFramePr/>
-          <p:nvPr/>
-        </p:nvGraphicFramePr>
-        <p:xfrm>
-          <a:off x="411480" y="1005840"/>
-          <a:ext cx="3931920" cy="2651760"/>
-        </p:xfrm>
-        <a:graphic xmlns:a="http://schemas.openxmlformats.org/drawingml/2006/main">
-          <a:graphicData uri="http://schemas.openxmlformats.org/drawingml/2006/chart">
-            <c:chart xmlns:c="http://schemas.openxmlformats.org/drawingml/2006/chart" r:id="rId1"/>
-          </a:graphicData>
-        </a:graphic>
-      </p:graphicFrame>
+      <p:pic>
+        <p:nvPicPr>
+          <p:cNvPr id="4" name="h1-chart" descr="/Users/kaoleangseng/Downloads/devops2-assessment2-main 2/assessment2/figures/slide_h1.png">    </p:cNvPr>
+          <p:cNvPicPr>
+            <a:picLocks noChangeAspect="1"/>
+          </p:cNvPicPr>
+          <p:nvPr/>
+        </p:nvPicPr>
+        <p:blipFill>
+          <a:blip r:embed="rId1"/>
+          <a:stretch>
+            <a:fillRect/>
+          </a:stretch>
+        </p:blipFill>
+        <p:spPr>
+          <a:xfrm>
+            <a:off x="548640" y="960120"/>
+            <a:ext cx="3566160" cy="2715768"/>
+          </a:xfrm>
+          <a:prstGeom prst="rect">
+            <a:avLst/>
+          </a:prstGeom>
+        </p:spPr>
+      </p:pic>
       <p:sp>
         <p:nvSpPr>
           <p:cNvPr id="5" name="Text 2"/>
@@ -16243,22 +15673,181 @@
           </a:p>
         </p:txBody>
       </p:sp>
-      <p:graphicFrame>
-        <p:nvGraphicFramePr>
-          <p:cNvPr id="16" name="phase-chart" descr=""/>
-          <p:cNvGraphicFramePr/>
-          <p:nvPr/>
-        </p:nvGraphicFramePr>
-        <p:xfrm>
-          <a:off x="2651760" y="1005840"/>
-          <a:ext cx="6080760" cy="3703320"/>
-        </p:xfrm>
-        <a:graphic xmlns:a="http://schemas.openxmlformats.org/drawingml/2006/main">
-          <a:graphicData uri="http://schemas.openxmlformats.org/drawingml/2006/chart">
-            <c:chart xmlns:c="http://schemas.openxmlformats.org/drawingml/2006/chart" r:id="rId1"/>
-          </a:graphicData>
-        </a:graphic>
-      </p:graphicFrame>
+      <p:pic>
+        <p:nvPicPr>
+          <p:cNvPr id="16" name="phase-chart" descr="/Users/kaoleangseng/Downloads/devops2-assessment2-main 2/assessment2/figures/slide_phases.png">    </p:cNvPr>
+          <p:cNvPicPr>
+            <a:picLocks noChangeAspect="1"/>
+          </p:cNvPicPr>
+          <p:nvPr/>
+        </p:nvPicPr>
+        <p:blipFill>
+          <a:blip r:embed="rId1"/>
+          <a:stretch>
+            <a:fillRect/>
+          </a:stretch>
+        </p:blipFill>
+        <p:spPr>
+          <a:xfrm>
+            <a:off x="2606040" y="1024128"/>
+            <a:ext cx="6126480" cy="2212848"/>
+          </a:xfrm>
+          <a:prstGeom prst="rect">
+            <a:avLst/>
+          </a:prstGeom>
+        </p:spPr>
+      </p:pic>
+      <p:sp>
+        <p:nvSpPr>
+          <p:cNvPr id="17" name="read-card"/>
+          <p:cNvSpPr/>
+          <p:nvPr/>
+        </p:nvSpPr>
+        <p:spPr>
+          <a:xfrm>
+            <a:off x="2606040" y="3383280"/>
+            <a:ext cx="6126480" cy="1362456"/>
+          </a:xfrm>
+          <a:prstGeom prst="roundRect">
+            <a:avLst>
+              <a:gd name="adj" fmla="val 5369"/>
+            </a:avLst>
+          </a:prstGeom>
+          <a:solidFill>
+            <a:srgbClr val="F1F0F7"/>
+          </a:solidFill>
+          <a:ln w="12700">
+            <a:solidFill>
+              <a:srgbClr val="F1F0F7"/>
+            </a:solidFill>
+            <a:prstDash val="solid"/>
+          </a:ln>
+        </p:spPr>
+      </p:sp>
+      <p:sp>
+        <p:nvSpPr>
+          <p:cNvPr id="18" name="Text 15"/>
+          <p:cNvSpPr txBox="1"/>
+          <p:nvPr/>
+        </p:nvSpPr>
+        <p:spPr>
+          <a:xfrm>
+            <a:off x="2788920" y="3474720"/>
+            <a:ext cx="2743200" cy="201168"/>
+          </a:xfrm>
+          <a:prstGeom prst="rect">
+            <a:avLst/>
+          </a:prstGeom>
+          <a:noFill/>
+          <a:ln/>
+        </p:spPr>
+        <p:txBody>
+          <a:bodyPr wrap="square" lIns="0" tIns="0" rIns="0" bIns="0" rtlCol="0" anchor="ctr"/>
+          <a:lstStyle/>
+          <a:p>
+            <a:pPr indent="0" marL="0">
+              <a:buNone/>
+            </a:pPr>
+            <a:r>
+              <a:rPr lang="en-US" sz="950" b="1" dirty="0">
+                <a:solidFill>
+                  <a:srgbClr val="E39A3B"/>
+                </a:solidFill>
+                <a:latin typeface="Calibri" pitchFamily="34" charset="0"/>
+                <a:ea typeface="Calibri" pitchFamily="34" charset="-122"/>
+                <a:cs typeface="Calibri" pitchFamily="34" charset="-120"/>
+              </a:rPr>
+              <a:t>HOW TO READ IT</a:t>
+            </a:r>
+            <a:endParaRPr lang="en-US" sz="950" dirty="0"/>
+          </a:p>
+        </p:txBody>
+      </p:sp>
+      <p:sp>
+        <p:nvSpPr>
+          <p:cNvPr id="19" name="read-body"/>
+          <p:cNvSpPr txBox="1"/>
+          <p:nvPr/>
+        </p:nvSpPr>
+        <p:spPr>
+          <a:xfrm>
+            <a:off x="2788920" y="3712464"/>
+            <a:ext cx="5806440" cy="987552"/>
+          </a:xfrm>
+          <a:prstGeom prst="rect">
+            <a:avLst/>
+          </a:prstGeom>
+          <a:noFill/>
+          <a:ln/>
+        </p:spPr>
+        <p:txBody>
+          <a:bodyPr wrap="square" lIns="0" tIns="0" rIns="0" bIns="0" rtlCol="0" anchor="t"/>
+          <a:lstStyle/>
+          <a:p>
+            <a:pPr marL="342900" indent="-342900">
+              <a:spcAft>
+                <a:spcPts val="200"/>
+              </a:spcAft>
+              <a:buSzPct val="100000"/>
+              <a:buChar char="•"/>
+            </a:pPr>
+            <a:r>
+              <a:rPr lang="en-US" sz="1050" dirty="0">
+                <a:solidFill>
+                  <a:srgbClr val="1E1A2B"/>
+                </a:solidFill>
+                <a:latin typeface="Calibri" pitchFamily="34" charset="0"/>
+                <a:ea typeface="Calibri" pitchFamily="34" charset="-122"/>
+                <a:cs typeface="Calibri" pitchFamily="34" charset="-120"/>
+              </a:rPr>
+              <a:t>Removing takes longer than building: 20.1 min vs 8.3 min. The five service stacks alone take 18.2 min.</a:t>
+            </a:r>
+            <a:endParaRPr lang="en-US" sz="1050" dirty="0"/>
+          </a:p>
+          <a:p>
+            <a:pPr marL="342900" indent="-342900">
+              <a:spcAft>
+                <a:spcPts val="200"/>
+              </a:spcAft>
+              <a:buSzPct val="100000"/>
+              <a:buChar char="•"/>
+            </a:pPr>
+            <a:r>
+              <a:rPr lang="en-US" sz="1050" dirty="0">
+                <a:solidFill>
+                  <a:srgbClr val="1E1A2B"/>
+                </a:solidFill>
+                <a:latin typeface="Calibri" pitchFamily="34" charset="0"/>
+                <a:ea typeface="Calibri" pitchFamily="34" charset="-122"/>
+                <a:cs typeface="Calibri" pitchFamily="34" charset="-120"/>
+              </a:rPr>
+              <a:t>The stacks are destroyed one after another, about 3.6 min each, so this one step sets the cycle length.</a:t>
+            </a:r>
+            <a:endParaRPr lang="en-US" sz="1050" dirty="0"/>
+          </a:p>
+          <a:p>
+            <a:pPr marL="342900" indent="-342900">
+              <a:spcAft>
+                <a:spcPts val="200"/>
+              </a:spcAft>
+              <a:buSzPct val="100000"/>
+              <a:buChar char="•"/>
+            </a:pPr>
+            <a:r>
+              <a:rPr lang="en-US" sz="1050" dirty="0">
+                <a:solidFill>
+                  <a:srgbClr val="1E1A2B"/>
+                </a:solidFill>
+                <a:latin typeface="Calibri" pitchFamily="34" charset="0"/>
+                <a:ea typeface="Calibri" pitchFamily="34" charset="-122"/>
+                <a:cs typeface="Calibri" pitchFamily="34" charset="-120"/>
+              </a:rPr>
+              <a:t>Short whiskers = consistent runs: each phase varies by seconds, not minutes (build SD 21 s).</a:t>
+            </a:r>
+            <a:endParaRPr lang="en-US" sz="1050" dirty="0"/>
+          </a:p>
+        </p:txBody>
+      </p:sp>
     </p:spTree>
   </p:cSld>
   <p:clrMapOvr>

</xml_diff>